<commit_message>
Polish repository for public release
</commit_message>
<xml_diff>
--- a/publication/ibic2026/poster/build/ibic2026-abstract54-poster.pptx
+++ b/publication/ibic2026/poster/build/ibic2026-abstract54-poster.pptx
@@ -2,111 +2,16 @@
 <file path=ppt/presentation.xml><?xml version="1.0" encoding="utf-8"?>
 <p:presentation xmlns:p="http://schemas.openxmlformats.org/presentationml/2006/main">
   <p:sldMasterIdLst>
-    <p:sldMasterId xmlns:r="http://schemas.openxmlformats.org/officeDocument/2006/relationships" id="2147483648" r:id="Re511c7ad39124bec"/>
+    <p:sldMasterId xmlns:r="http://schemas.openxmlformats.org/officeDocument/2006/relationships" id="2147483648" r:id="R6033c1f21ee84a46"/>
   </p:sldMasterIdLst>
   <p:notesMasterIdLst>
-    <p:notesMasterId xmlns:r="http://schemas.openxmlformats.org/officeDocument/2006/relationships" r:id="R04a889acadbc484a"/>
+    <p:notesMasterId xmlns:r="http://schemas.openxmlformats.org/officeDocument/2006/relationships" r:id="R40b60bfa08a84e1f"/>
   </p:notesMasterIdLst>
   <p:sldIdLst>
-    <p:sldId xmlns:r="http://schemas.openxmlformats.org/officeDocument/2006/relationships" id="256" r:id="R5c3f1ce47d324025"/>
+    <p:sldId xmlns:r="http://schemas.openxmlformats.org/officeDocument/2006/relationships" id="256" r:id="R3e644e6eb4df4e1b"/>
   </p:sldIdLst>
   <p:sldSz cx="30267275" cy="42794238"/>
   <p:notesSz cx="6858000" cy="9144000"/>
-  <p:defaultTextStyle>
-    <a:defPPr xmlns:a="http://schemas.openxmlformats.org/drawingml/2006/main">
-      <a:defRPr lang="en-US"/>
-    </a:defPPr>
-    <a:lvl1pPr xmlns:a="http://schemas.openxmlformats.org/drawingml/2006/main" marL="0" indent="0" algn="l" defTabSz="914400">
-      <a:defRPr sz="1800" kern="1200">
-        <a:solidFill>
-          <a:schemeClr val="tx1"/>
-        </a:solidFill>
-        <a:latin typeface="+mn-lt"/>
-        <a:ea typeface="+mn-ea"/>
-        <a:cs typeface="+mn-cs"/>
-      </a:defRPr>
-    </a:lvl1pPr>
-    <a:lvl2pPr xmlns:a="http://schemas.openxmlformats.org/drawingml/2006/main" marL="457200" indent="0" algn="l" defTabSz="914400">
-      <a:defRPr sz="1800" kern="1200">
-        <a:solidFill>
-          <a:schemeClr val="tx1"/>
-        </a:solidFill>
-        <a:latin typeface="+mn-lt"/>
-        <a:ea typeface="+mn-ea"/>
-        <a:cs typeface="+mn-cs"/>
-      </a:defRPr>
-    </a:lvl2pPr>
-    <a:lvl3pPr xmlns:a="http://schemas.openxmlformats.org/drawingml/2006/main" marL="914400" indent="0" algn="l" defTabSz="914400">
-      <a:defRPr sz="1800" kern="1200">
-        <a:solidFill>
-          <a:schemeClr val="tx1"/>
-        </a:solidFill>
-        <a:latin typeface="+mn-lt"/>
-        <a:ea typeface="+mn-ea"/>
-        <a:cs typeface="+mn-cs"/>
-      </a:defRPr>
-    </a:lvl3pPr>
-    <a:lvl4pPr xmlns:a="http://schemas.openxmlformats.org/drawingml/2006/main" marL="1371600" indent="0" algn="l" defTabSz="914400">
-      <a:defRPr sz="1800" kern="1200">
-        <a:solidFill>
-          <a:schemeClr val="tx1"/>
-        </a:solidFill>
-        <a:latin typeface="+mn-lt"/>
-        <a:ea typeface="+mn-ea"/>
-        <a:cs typeface="+mn-cs"/>
-      </a:defRPr>
-    </a:lvl4pPr>
-    <a:lvl5pPr xmlns:a="http://schemas.openxmlformats.org/drawingml/2006/main" marL="1828800" indent="0" algn="l" defTabSz="914400">
-      <a:defRPr sz="1800" kern="1200">
-        <a:solidFill>
-          <a:schemeClr val="tx1"/>
-        </a:solidFill>
-        <a:latin typeface="+mn-lt"/>
-        <a:ea typeface="+mn-ea"/>
-        <a:cs typeface="+mn-cs"/>
-      </a:defRPr>
-    </a:lvl5pPr>
-    <a:lvl6pPr xmlns:a="http://schemas.openxmlformats.org/drawingml/2006/main" marL="2286000" indent="0" algn="l" defTabSz="914400">
-      <a:defRPr sz="1800" kern="1200">
-        <a:solidFill>
-          <a:schemeClr val="tx1"/>
-        </a:solidFill>
-        <a:latin typeface="+mn-lt"/>
-        <a:ea typeface="+mn-ea"/>
-        <a:cs typeface="+mn-cs"/>
-      </a:defRPr>
-    </a:lvl6pPr>
-    <a:lvl7pPr xmlns:a="http://schemas.openxmlformats.org/drawingml/2006/main" marL="2743200" indent="0" algn="l" defTabSz="914400">
-      <a:defRPr sz="1800" kern="1200">
-        <a:solidFill>
-          <a:schemeClr val="tx1"/>
-        </a:solidFill>
-        <a:latin typeface="+mn-lt"/>
-        <a:ea typeface="+mn-ea"/>
-        <a:cs typeface="+mn-cs"/>
-      </a:defRPr>
-    </a:lvl7pPr>
-    <a:lvl8pPr xmlns:a="http://schemas.openxmlformats.org/drawingml/2006/main" marL="3200400" indent="0" algn="l" defTabSz="914400">
-      <a:defRPr sz="1800" kern="1200">
-        <a:solidFill>
-          <a:schemeClr val="tx1"/>
-        </a:solidFill>
-        <a:latin typeface="+mn-lt"/>
-        <a:ea typeface="+mn-ea"/>
-        <a:cs typeface="+mn-cs"/>
-      </a:defRPr>
-    </a:lvl8pPr>
-    <a:lvl9pPr xmlns:a="http://schemas.openxmlformats.org/drawingml/2006/main" marL="3657600" indent="0" algn="l" defTabSz="914400">
-      <a:defRPr sz="1800" kern="1200">
-        <a:solidFill>
-          <a:schemeClr val="tx1"/>
-        </a:solidFill>
-        <a:latin typeface="+mn-lt"/>
-        <a:ea typeface="+mn-ea"/>
-        <a:cs typeface="+mn-cs"/>
-      </a:defRPr>
-    </a:lvl9pPr>
-  </p:defaultTextStyle>
 </p:presentation>
 </file>
 
@@ -558,7 +463,36 @@
         <p:txBody>
           <a:bodyPr xmlns:a="http://schemas.openxmlformats.org/drawingml/2006/main"/>
           <a:lstStyle xmlns:a="http://schemas.openxmlformats.org/drawingml/2006/main"/>
-          <a:p xmlns:a="http://schemas.openxmlformats.org/drawingml/2006/main"/>
+          <a:p xmlns:a="http://schemas.openxmlformats.org/drawingml/2006/main">
+            <a:r>
+              <a:t>[Sources]</a:t>
+            </a:r>
+          </a:p>
+          <a:p xmlns:a="http://schemas.openxmlformats.org/drawingml/2006/main">
+            <a:r>
+              <a:t>- Accepted paper evidence: publication/ibic2026/results_payload.json (poster evidence gate).</a:t>
+            </a:r>
+          </a:p>
+          <a:p xmlns:a="http://schemas.openxmlformats.org/drawingml/2006/main">
+            <a:r>
+              <a:t>- H and V validation plus ridge-density graphics: publication/ibic2026/reports/publication_figures/poster/.</a:t>
+            </a:r>
+          </a:p>
+          <a:p xmlns:a="http://schemas.openxmlformats.org/drawingml/2006/main">
+            <a:r>
+              <a:t>- Beamline map: Delivery Ring BPM Status 7-16-2026 - DAS .pptx, slide 2; George Deinlein, Fermilab staff; used with full permission confirmed 2026-08-19; extracted asset SHA-256 7422ad58a659d6149139180bd6d35cd1fc9bd05ba94af6314f9fceb069278ce6.</a:t>
+            </a:r>
+          </a:p>
+          <a:p xmlns:a="http://schemas.openxmlformats.org/drawingml/2006/main">
+            <a:r>
+              <a:t>- Fermilab publication requirements: FERMILAB-POSTER-26-0268-AD; This manuscript has been authored by FermiForward Discovery Group, LLC under Contract No. 89243024CSC000002 with the U.S. Department of Energy, Office of Science, Office of High Energy Physics.</a:t>
+            </a:r>
+          </a:p>
+          <a:p xmlns:a="http://schemas.openxmlformats.org/drawingml/2006/main">
+            <a:r>
+              <a:t>- Print submission: final PDF to Cindy Arnold &lt;carnold@fnal.gov&gt;.</a:t>
+            </a:r>
+          </a:p>
         </p:txBody>
       </p:sp>
       <p:sp>
@@ -3118,7 +3052,7 @@
           <p:nvPr/>
         </p:nvPicPr>
         <p:blipFill>
-          <a:blip xmlns:r="http://schemas.openxmlformats.org/officeDocument/2006/relationships" xmlns:a="http://schemas.openxmlformats.org/drawingml/2006/main" r:embed="R533327c006234bb1"/>
+          <a:blip xmlns:r="http://schemas.openxmlformats.org/officeDocument/2006/relationships" xmlns:a="http://schemas.openxmlformats.org/drawingml/2006/main" r:embed="Rea81999d99ed45fb"/>
           <a:srcRect xmlns:a="http://schemas.openxmlformats.org/drawingml/2006/main" l="0" t="0" r="0" b="0"/>
           <a:stretch xmlns:a="http://schemas.openxmlformats.org/drawingml/2006/main"/>
         </p:blipFill>
@@ -3195,8 +3129,8 @@
   </p:cSld>
   <p:clrMap bg1="lt1" tx1="dk1" bg2="lt2" tx2="dk2" accent1="accent1" accent2="accent2" accent3="accent3" accent4="accent4" accent5="accent5" accent6="accent6" hlink="hlink" folHlink="folHlink"/>
   <p:sldLayoutIdLst>
-    <p:sldLayoutId xmlns:r="http://schemas.openxmlformats.org/officeDocument/2006/relationships" id="2147483649" r:id="Ra755089009414e34"/>
-    <p:sldLayoutId xmlns:r="http://schemas.openxmlformats.org/officeDocument/2006/relationships" id="2147483650" r:id="Re96ed9b0b98d431f"/>
+    <p:sldLayoutId xmlns:r="http://schemas.openxmlformats.org/officeDocument/2006/relationships" id="2147483649" r:id="Rb2d51af6c0e74f92"/>
+    <p:sldLayoutId xmlns:r="http://schemas.openxmlformats.org/officeDocument/2006/relationships" id="2147483650" r:id="R10224f69302e4341"/>
   </p:sldLayoutIdLst>
   <p:txStyles>
     <p:titleStyle>
@@ -3727,12 +3661,12 @@
               </a:defRPr>
             </a:pPr>
             <a:r>
-              <a:rPr sz="9000">
+              <a:rPr sz="9600" b="1">
                 <a:latin typeface="Arial"/>
                 <a:ea typeface="Arial"/>
                 <a:cs typeface="Arial"/>
               </a:rPr>
-              <a:t>Turn-by-turn tune analysis using adaptive BPM ensembles in the Fermilab Mu2e Delivery Ring</a:t>
+              <a:t>Which BPMs can we trust, spill by spill?</a:t>
             </a:r>
           </a:p>
           <a:p xmlns:a="http://schemas.openxmlformats.org/drawingml/2006/main">
@@ -3744,7 +3678,24 @@
               </a:defRPr>
             </a:pPr>
             <a:r>
-              <a:rPr sz="5200" b="0">
+              <a:rPr sz="4650" b="0">
+                <a:latin typeface="Arial"/>
+                <a:ea typeface="Arial"/>
+                <a:cs typeface="Arial"/>
+              </a:rPr>
+              <a:t>Adaptive turn-by-turn tune analysis in the Mu2e Delivery Ring</a:t>
+            </a:r>
+          </a:p>
+          <a:p xmlns:a="http://schemas.openxmlformats.org/drawingml/2006/main">
+            <a:pPr>
+              <a:defRPr>
+                <a:latin typeface="Arial"/>
+                <a:ea typeface="Arial"/>
+                <a:cs typeface="Arial"/>
+              </a:defRPr>
+            </a:pPr>
+            <a:r>
+              <a:rPr sz="3375" b="0">
                 <a:latin typeface="Arial"/>
                 <a:ea typeface="Arial"/>
                 <a:cs typeface="Arial"/>
@@ -3752,11 +3703,6 @@
               <a:t>Derek Steinkamp | Fermi National Accelerator Laboratory</a:t>
             </a:r>
           </a:p>
-          <a:p xmlns:a="http://schemas.openxmlformats.org/drawingml/2006/main">
-            <a:r>
-              <a:t/>
-            </a:r>
-          </a:p>
         </p:txBody>
       </p:sp>
       <p:sp>
@@ -3777,28 +3723,34 @@
         </p:nvSpPr>
         <p:spPr>
           <a:xfrm xmlns:a="http://schemas.openxmlformats.org/drawingml/2006/main">
-            <a:off x="869950" y="33243268"/>
-            <a:ext cx="19248120" cy="1234440"/>
-          </a:xfrm>
-        </p:spPr>
-        <p:txBody>
-          <a:bodyPr xmlns:a="http://schemas.openxmlformats.org/drawingml/2006/main"/>
+            <a:off x="15685770" y="32623125"/>
+            <a:ext cx="13668375" cy="857250"/>
+          </a:xfrm>
+        </p:spPr>
+        <p:txBody>
+          <a:bodyPr xmlns:a="http://schemas.openxmlformats.org/drawingml/2006/main" anchor="ctr"/>
           <a:lstStyle xmlns:a="http://schemas.openxmlformats.org/drawingml/2006/main"/>
           <a:p xmlns:a="http://schemas.openxmlformats.org/drawingml/2006/main">
             <a:pPr>
-              <a:defRPr>
+              <a:defRPr sz="4050" b="1">
+                <a:solidFill>
+                  <a:srgbClr val="004C97"/>
+                </a:solidFill>
                 <a:latin typeface="Arial"/>
                 <a:ea typeface="Arial"/>
                 <a:cs typeface="Arial"/>
               </a:defRPr>
             </a:pPr>
             <a:r>
-              <a:rPr>
+              <a:rPr sz="4050" b="1">
+                <a:solidFill>
+                  <a:srgbClr val="004C97"/>
+                </a:solidFill>
                 <a:latin typeface="Arial"/>
                 <a:ea typeface="Arial"/>
                 <a:cs typeface="Arial"/>
               </a:rPr>
-              <a:t>RESULT AND LIMIT</a:t>
+              <a:t>WHAT DID WE LEARN?</a:t>
             </a:r>
           </a:p>
         </p:txBody>
@@ -3821,8 +3773,8 @@
         </p:nvSpPr>
         <p:spPr>
           <a:xfrm xmlns:a="http://schemas.openxmlformats.org/drawingml/2006/main">
-            <a:off x="20987429" y="33011244"/>
-            <a:ext cx="8366760" cy="1449970"/>
+            <a:off x="869918" y="40052625"/>
+            <a:ext cx="17145000" cy="1666875"/>
           </a:xfrm>
         </p:spPr>
         <p:txBody>
@@ -3830,283 +3782,379 @@
           <a:lstStyle xmlns:a="http://schemas.openxmlformats.org/drawingml/2006/main"/>
           <a:p xmlns:a="http://schemas.openxmlformats.org/drawingml/2006/main">
             <a:pPr>
-              <a:defRPr>
+              <a:defRPr sz="1725" b="0">
+                <a:solidFill>
+                  <a:srgbClr val="FFFFFF"/>
+                </a:solidFill>
                 <a:latin typeface="Arial"/>
                 <a:ea typeface="Arial"/>
                 <a:cs typeface="Arial"/>
               </a:defRPr>
             </a:pPr>
             <a:r>
-              <a:rPr>
+              <a:rPr sz="1725" b="0">
+                <a:solidFill>
+                  <a:srgbClr val="FFFFFF"/>
+                </a:solidFill>
                 <a:latin typeface="Arial"/>
                 <a:ea typeface="Arial"/>
                 <a:cs typeface="Arial"/>
               </a:rPr>
-              <a:t>Best-5 H concentration is tracked over 50,000 turns. Sustained half-peak loss begins near turn 5632. The multimetric change candidate is turn 5760. No extraction timestamp or cause is inferred.</a:t>
-            </a:r>
-          </a:p>
-        </p:txBody>
-      </p:sp>
-      <p:sp>
-        <p:nvSpPr>
-          <p:cNvPr id="34" name="Text Placeholder 17">
-            <a:extLst xmlns:a="http://schemas.openxmlformats.org/drawingml/2006/main">
-              <a:ext uri="{FF2B5EF4-FFF2-40B4-BE49-F238E27FC236}">
-                <a16:creationId xmlns:a16="http://schemas.microsoft.com/office/drawing/2014/main" id="{C522ABAA-F5B2-46AE-A228-D8A1D25D9604}"/>
-              </a:ext>
-            </a:extLst>
-          </p:cNvPr>
-          <p:cNvSpPr>
-            <a:spLocks xmlns:a="http://schemas.openxmlformats.org/drawingml/2006/main" noGrp="1"/>
-          </p:cNvSpPr>
-          <p:nvPr>
-            <p:ph type="body" idx="39"/>
-          </p:nvPr>
-        </p:nvSpPr>
-        <p:spPr/>
-        <p:txBody>
-          <a:bodyPr xmlns:a="http://schemas.openxmlformats.org/drawingml/2006/main"/>
-          <a:lstStyle xmlns:a="http://schemas.openxmlformats.org/drawingml/2006/main"/>
+              <a:t>This manuscript has been authored by FermiForward Discovery Group, LLC under Contract No. 89243024CSC000002 with the U.S. Department of Energy, Office of Science, Office of High Energy Physics.</a:t>
+            </a:r>
+          </a:p>
           <a:p xmlns:a="http://schemas.openxmlformats.org/drawingml/2006/main">
             <a:pPr>
-              <a:defRPr>
+              <a:defRPr sz="1725" b="0">
+                <a:solidFill>
+                  <a:srgbClr val="FFFFFF"/>
+                </a:solidFill>
                 <a:latin typeface="Arial"/>
                 <a:ea typeface="Arial"/>
                 <a:cs typeface="Arial"/>
               </a:defRPr>
             </a:pPr>
             <a:r>
-              <a:rPr>
+              <a:rPr sz="1725" b="0">
+                <a:solidFill>
+                  <a:srgbClr val="FFFFFF"/>
+                </a:solidFill>
                 <a:latin typeface="Arial"/>
                 <a:ea typeface="Arial"/>
                 <a:cs typeface="Arial"/>
               </a:rPr>
-              <a:t>ADAPTIVE, LEAKAGE-CONTROLLED BPM ENSEMBLES</a:t>
-            </a:r>
-          </a:p>
-        </p:txBody>
-      </p:sp>
-      <p:sp>
-        <p:nvSpPr>
-          <p:cNvPr id="36" name="Text Placeholder 18">
-            <a:extLst xmlns:a="http://schemas.openxmlformats.org/drawingml/2006/main">
-              <a:ext uri="{FF2B5EF4-FFF2-40B4-BE49-F238E27FC236}">
-                <a16:creationId xmlns:a16="http://schemas.microsoft.com/office/drawing/2014/main" id="{57FE9931-39F7-4355-96BE-BC674C817037}"/>
-              </a:ext>
-            </a:extLst>
-          </p:cNvPr>
-          <p:cNvSpPr>
-            <a:spLocks xmlns:a="http://schemas.openxmlformats.org/drawingml/2006/main" noGrp="1"/>
-          </p:cNvSpPr>
-          <p:nvPr>
-            <p:ph type="body" idx="40"/>
-          </p:nvPr>
-        </p:nvSpPr>
-        <p:spPr>
-          <a:xfrm xmlns:a="http://schemas.openxmlformats.org/drawingml/2006/main">
-            <a:off x="869950" y="9107514"/>
-            <a:ext cx="19243675" cy="3510843"/>
-          </a:xfrm>
-        </p:spPr>
-        <p:txBody>
-          <a:bodyPr xmlns:a="http://schemas.openxmlformats.org/drawingml/2006/main"/>
+              <a:t>Beamline layout courtesy of George Deinlein, Fermilab staff; used with permission.</a:t>
+            </a:r>
+          </a:p>
+        </p:txBody>
+      </p:sp>
+      <p:sp>
+        <p:nvSpPr>
+          <p:cNvPr id="34" name="Text Placeholder 17">
+            <a:extLst xmlns:a="http://schemas.openxmlformats.org/drawingml/2006/main">
+              <a:ext uri="{FF2B5EF4-FFF2-40B4-BE49-F238E27FC236}">
+                <a16:creationId xmlns:a16="http://schemas.microsoft.com/office/drawing/2014/main" id="{C522ABAA-F5B2-46AE-A228-D8A1D25D9604}"/>
+              </a:ext>
+            </a:extLst>
+          </p:cNvPr>
+          <p:cNvSpPr>
+            <a:spLocks xmlns:a="http://schemas.openxmlformats.org/drawingml/2006/main" noGrp="1"/>
+          </p:cNvSpPr>
+          <p:nvPr>
+            <p:ph type="body" idx="39"/>
+          </p:nvPr>
+        </p:nvSpPr>
+        <p:spPr>
+          <a:xfrm xmlns:a="http://schemas.openxmlformats.org/drawingml/2006/main">
+            <a:off x="869918" y="22145625"/>
+            <a:ext cx="28484227" cy="952500"/>
+          </a:xfrm>
+        </p:spPr>
+        <p:txBody>
+          <a:bodyPr xmlns:a="http://schemas.openxmlformats.org/drawingml/2006/main" anchor="ctr"/>
           <a:lstStyle xmlns:a="http://schemas.openxmlformats.org/drawingml/2006/main"/>
           <a:p xmlns:a="http://schemas.openxmlformats.org/drawingml/2006/main">
             <a:pPr>
-              <a:buNone/>
-              <a:defRPr>
+              <a:defRPr sz="4500" b="1">
+                <a:solidFill>
+                  <a:srgbClr val="004C97"/>
+                </a:solidFill>
                 <a:latin typeface="Arial"/>
                 <a:ea typeface="Arial"/>
                 <a:cs typeface="Arial"/>
               </a:defRPr>
             </a:pPr>
             <a:r>
-              <a:rPr>
+              <a:rPr sz="4500" b="1">
+                <a:solidFill>
+                  <a:srgbClr val="004C97"/>
+                </a:solidFill>
                 <a:latin typeface="Arial"/>
                 <a:ea typeface="Arial"/>
                 <a:cs typeface="Arial"/>
               </a:rPr>
-              <a:t>Synchronized 2,000-spill raw snapshots use a nominal 60 H / 60 V topology; 16 source absences across 12 flagged partial captures are hash-bound.</a:t>
-            </a:r>
-          </a:p>
+              <a:t>THERE IS NO SINGLE BEST BPM</a:t>
+            </a:r>
+          </a:p>
+        </p:txBody>
+      </p:sp>
+      <p:sp>
+        <p:nvSpPr>
+          <p:cNvPr id="36" name="Text Placeholder 18">
+            <a:extLst xmlns:a="http://schemas.openxmlformats.org/drawingml/2006/main">
+              <a:ext uri="{FF2B5EF4-FFF2-40B4-BE49-F238E27FC236}">
+                <a16:creationId xmlns:a16="http://schemas.microsoft.com/office/drawing/2014/main" id="{57FE9931-39F7-4355-96BE-BC674C817037}"/>
+              </a:ext>
+            </a:extLst>
+          </p:cNvPr>
+          <p:cNvSpPr>
+            <a:spLocks xmlns:a="http://schemas.openxmlformats.org/drawingml/2006/main" noGrp="1"/>
+          </p:cNvSpPr>
+          <p:nvPr>
+            <p:ph type="body" idx="40"/>
+          </p:nvPr>
+        </p:nvSpPr>
+        <p:spPr>
+          <a:xfrm xmlns:a="http://schemas.openxmlformats.org/drawingml/2006/main">
+            <a:off x="869918" y="23098125"/>
+            <a:ext cx="28484227" cy="1047750"/>
+          </a:xfrm>
+        </p:spPr>
+        <p:txBody>
+          <a:bodyPr xmlns:a="http://schemas.openxmlformats.org/drawingml/2006/main"/>
+          <a:lstStyle xmlns:a="http://schemas.openxmlformats.org/drawingml/2006/main"/>
           <a:p xmlns:a="http://schemas.openxmlformats.org/drawingml/2006/main">
             <a:pPr>
-              <a:defRPr>
+              <a:buNone/>
+              <a:defRPr sz="3300" b="0">
+                <a:solidFill>
+                  <a:srgbClr val="000000"/>
+                </a:solidFill>
                 <a:latin typeface="Arial"/>
                 <a:ea typeface="Arial"/>
                 <a:cs typeface="Arial"/>
               </a:defRPr>
             </a:pPr>
             <a:r>
-              <a:rPr>
+              <a:rPr sz="3300" b="0">
+                <a:solidFill>
+                  <a:srgbClr val="000000"/>
+                </a:solidFill>
                 <a:latin typeface="Arial"/>
                 <a:ea typeface="Arial"/>
                 <a:cs typeface="Arial"/>
               </a:rPr>
-              <a:t>Scaled threshold-substituted streams are excluded; members use eight fit windows with overlap purged.</a:t>
-            </a:r>
-          </a:p>
+              <a:t>All 60 H and 60 V sources win at least once. Choose early; test later with held-out digitizers.</a:t>
+            </a:r>
+          </a:p>
+        </p:txBody>
+      </p:sp>
+      <p:sp>
+        <p:nvSpPr>
+          <p:cNvPr id="39" name="Text Placeholder 19">
+            <a:extLst xmlns:a="http://schemas.openxmlformats.org/drawingml/2006/main">
+              <a:ext uri="{FF2B5EF4-FFF2-40B4-BE49-F238E27FC236}">
+                <a16:creationId xmlns:a16="http://schemas.microsoft.com/office/drawing/2014/main" id="{AA4A1BB5-06FE-4892-B35D-3A62722303AC}"/>
+              </a:ext>
+            </a:extLst>
+          </p:cNvPr>
+          <p:cNvSpPr>
+            <a:spLocks xmlns:a="http://schemas.openxmlformats.org/drawingml/2006/main" noGrp="1"/>
+          </p:cNvSpPr>
+          <p:nvPr>
+            <p:ph type="body" idx="41"/>
+          </p:nvPr>
+        </p:nvSpPr>
+        <p:spPr>
+          <a:xfrm xmlns:a="http://schemas.openxmlformats.org/drawingml/2006/main">
+            <a:off x="15685770" y="33528000"/>
+            <a:ext cx="13668375" cy="5095875"/>
+          </a:xfrm>
+        </p:spPr>
+        <p:txBody>
+          <a:bodyPr xmlns:a="http://schemas.openxmlformats.org/drawingml/2006/main"/>
+          <a:lstStyle xmlns:a="http://schemas.openxmlformats.org/drawingml/2006/main"/>
           <a:p xmlns:a="http://schemas.openxmlformats.org/drawingml/2006/main">
             <a:pPr>
-              <a:defRPr>
+              <a:defRPr sz="3150" b="0">
+                <a:solidFill>
+                  <a:srgbClr val="000000"/>
+                </a:solidFill>
                 <a:latin typeface="Arial"/>
                 <a:ea typeface="Arial"/>
                 <a:cs typeface="Arial"/>
               </a:defRPr>
             </a:pPr>
             <a:r>
-              <a:rPr>
+              <a:rPr sz="3150" b="0">
+                <a:solidFill>
+                  <a:srgbClr val="000000"/>
+                </a:solidFill>
                 <a:latin typeface="Arial"/>
                 <a:ea typeface="Arial"/>
                 <a:cs typeface="Arial"/>
               </a:rPr>
-              <a:t>Later validation uses 1,000 stratified spill-plane cases across 5 held-out-digitizer folds.</a:t>
-            </a:r>
-          </a:p>
-        </p:txBody>
-      </p:sp>
-      <p:sp>
-        <p:nvSpPr>
-          <p:cNvPr id="39" name="Text Placeholder 19">
-            <a:extLst xmlns:a="http://schemas.openxmlformats.org/drawingml/2006/main">
-              <a:ext uri="{FF2B5EF4-FFF2-40B4-BE49-F238E27FC236}">
-                <a16:creationId xmlns:a16="http://schemas.microsoft.com/office/drawing/2014/main" id="{AA4A1BB5-06FE-4892-B35D-3A62722303AC}"/>
-              </a:ext>
-            </a:extLst>
-          </p:cNvPr>
-          <p:cNvSpPr>
-            <a:spLocks xmlns:a="http://schemas.openxmlformats.org/drawingml/2006/main" noGrp="1"/>
-          </p:cNvSpPr>
-          <p:nvPr>
-            <p:ph type="body" idx="41"/>
-          </p:nvPr>
-        </p:nvSpPr>
-        <p:spPr>
-          <a:xfrm xmlns:a="http://schemas.openxmlformats.org/drawingml/2006/main">
-            <a:off x="869950" y="34549047"/>
-            <a:ext cx="19243675" cy="3002468"/>
-          </a:xfrm>
-        </p:spPr>
-        <p:txBody>
-          <a:bodyPr xmlns:a="http://schemas.openxmlformats.org/drawingml/2006/main"/>
-          <a:lstStyle xmlns:a="http://schemas.openxmlformats.org/drawingml/2006/main"/>
+              <a:t>H Best-5 narrows the ridge. V Best-12 agrees more strongly. All-channel aggregation remains competitive.</a:t>
+            </a:r>
+          </a:p>
+          <a:p xmlns:a="http://schemas.openxmlformats.org/drawingml/2006/main">
+            <a:r>
+              <a:t/>
+            </a:r>
+          </a:p>
           <a:p xmlns:a="http://schemas.openxmlformats.org/drawingml/2006/main">
             <a:pPr>
-              <a:defRPr>
+              <a:defRPr sz="3150" b="0">
+                <a:solidFill>
+                  <a:srgbClr val="000000"/>
+                </a:solidFill>
                 <a:latin typeface="Arial"/>
                 <a:ea typeface="Arial"/>
                 <a:cs typeface="Arial"/>
               </a:defRPr>
             </a:pPr>
             <a:r>
-              <a:rPr>
+              <a:rPr sz="3150" b="0">
+                <a:solidFill>
+                  <a:srgbClr val="000000"/>
+                </a:solidFill>
                 <a:latin typeface="Arial"/>
                 <a:ea typeface="Arial"/>
                 <a:cs typeface="Arial"/>
               </a:rPr>
-              <a:t>Versus adaptive Best-1, H Best-5 and V Best-12 improve blind agreement and median selected/held-out tune delta, with power-support tradeoffs.</a:t>
+              <a:t>Useful operating points - not universal optima.</a:t>
+            </a:r>
+          </a:p>
+          <a:p xmlns:a="http://schemas.openxmlformats.org/drawingml/2006/main">
+            <a:r>
+              <a:t/>
             </a:r>
           </a:p>
           <a:p xmlns:a="http://schemas.openxmlformats.org/drawingml/2006/main">
             <a:pPr>
-              <a:defRPr>
+              <a:defRPr sz="3150" b="0">
+                <a:solidFill>
+                  <a:srgbClr val="000000"/>
+                </a:solidFill>
                 <a:latin typeface="Arial"/>
                 <a:ea typeface="Arial"/>
                 <a:cs typeface="Arial"/>
               </a:defRPr>
             </a:pPr>
             <a:r>
-              <a:rPr>
+              <a:rPr sz="3150" b="0">
+                <a:solidFill>
+                  <a:srgbClr val="000000"/>
+                </a:solidFill>
                 <a:latin typeface="Arial"/>
                 <a:ea typeface="Arial"/>
                 <a:cs typeface="Arial"/>
               </a:rPr>
-              <a:t>Full-buffer ensemble-size contrast: H narrower than corrected Best-1; V broader than corrected Best-1.</a:t>
-            </a:r>
-          </a:p>
-          <a:p xmlns:a="http://schemas.openxmlformats.org/drawingml/2006/main">
-            <a:pPr>
-              <a:defRPr>
+              <a:t>Is this the machine tune? Not yet. Next: change the tune on purpose (a controlled quadrupole scan) and ask whether the candidate follows.</a:t>
+            </a:r>
+          </a:p>
+        </p:txBody>
+      </p:sp>
+      <p:sp>
+        <p:nvSpPr>
+          <p:cNvPr id="40" name="Text Placeholder 20">
+            <a:extLst xmlns:a="http://schemas.openxmlformats.org/drawingml/2006/main">
+              <a:ext uri="{FF2B5EF4-FFF2-40B4-BE49-F238E27FC236}">
+                <a16:creationId xmlns:a16="http://schemas.microsoft.com/office/drawing/2014/main" id="{35506DCD-02DA-4D8B-9D24-E56CCC82B0F8}"/>
+              </a:ext>
+            </a:extLst>
+          </p:cNvPr>
+          <p:cNvSpPr>
+            <a:spLocks xmlns:a="http://schemas.openxmlformats.org/drawingml/2006/main" noGrp="1"/>
+          </p:cNvSpPr>
+          <p:nvPr>
+            <p:ph type="body" idx="42"/>
+          </p:nvPr>
+        </p:nvSpPr>
+        <p:spPr>
+          <a:xfrm xmlns:a="http://schemas.openxmlformats.org/drawingml/2006/main">
+            <a:off x="20764500" y="304800"/>
+            <a:ext cx="8572500" cy="552450"/>
+          </a:xfrm>
+        </p:spPr>
+        <p:txBody>
+          <a:bodyPr xmlns:a="http://schemas.openxmlformats.org/drawingml/2006/main" anchor="ctr"/>
+          <a:lstStyle xmlns:a="http://schemas.openxmlformats.org/drawingml/2006/main"/>
+          <a:p xmlns:a="http://schemas.openxmlformats.org/drawingml/2006/main">
+            <a:pPr algn="r">
+              <a:defRPr sz="2025" b="1">
+                <a:solidFill>
+                  <a:srgbClr val="FFFFFF"/>
+                </a:solidFill>
                 <a:latin typeface="Arial"/>
                 <a:ea typeface="Arial"/>
                 <a:cs typeface="Arial"/>
               </a:defRPr>
             </a:pPr>
             <a:r>
-              <a:rPr>
+              <a:rPr sz="2025" b="1">
+                <a:solidFill>
+                  <a:srgbClr val="FFFFFF"/>
+                </a:solidFill>
                 <a:latin typeface="Arial"/>
                 <a:ea typeface="Arial"/>
                 <a:cs typeface="Arial"/>
               </a:rPr>
-              <a:t>Same-protocol all-training control favors Best-N in H 2/8 and V 3/8 comparisons; it favors all-training in H 3/8 and V 3/8. No external tune calibration is claimed.</a:t>
-            </a:r>
-          </a:p>
-        </p:txBody>
-      </p:sp>
-      <p:sp>
-        <p:nvSpPr>
-          <p:cNvPr id="40" name="Text Placeholder 20">
-            <a:extLst xmlns:a="http://schemas.openxmlformats.org/drawingml/2006/main">
-              <a:ext uri="{FF2B5EF4-FFF2-40B4-BE49-F238E27FC236}">
-                <a16:creationId xmlns:a16="http://schemas.microsoft.com/office/drawing/2014/main" id="{35506DCD-02DA-4D8B-9D24-E56CCC82B0F8}"/>
-              </a:ext>
-            </a:extLst>
-          </p:cNvPr>
-          <p:cNvSpPr>
-            <a:spLocks xmlns:a="http://schemas.openxmlformats.org/drawingml/2006/main" noGrp="1"/>
-          </p:cNvSpPr>
-          <p:nvPr>
-            <p:ph type="body" idx="42"/>
-          </p:nvPr>
-        </p:nvSpPr>
-        <p:spPr>
-          <a:xfrm xmlns:a="http://schemas.openxmlformats.org/drawingml/2006/main">
-            <a:off x="20987430" y="20143411"/>
-            <a:ext cx="8366759" cy="6074527"/>
-          </a:xfrm>
-        </p:spPr>
-        <p:txBody>
-          <a:bodyPr xmlns:a="http://schemas.openxmlformats.org/drawingml/2006/main"/>
+              <a:t>FERMILAB-POSTER-26-0268-AD</a:t>
+            </a:r>
+          </a:p>
+        </p:txBody>
+      </p:sp>
+      <p:sp>
+        <p:nvSpPr>
+          <p:cNvPr id="11" name="Text Placeholder 10">
+            <a:extLst xmlns:a="http://schemas.openxmlformats.org/drawingml/2006/main">
+              <a:ext uri="{FF2B5EF4-FFF2-40B4-BE49-F238E27FC236}">
+                <a16:creationId xmlns:a16="http://schemas.microsoft.com/office/drawing/2014/main" id="{D951D0B9-C16D-478C-883C-FBEC31B356DB}"/>
+              </a:ext>
+            </a:extLst>
+          </p:cNvPr>
+          <p:cNvSpPr>
+            <a:spLocks xmlns:a="http://schemas.openxmlformats.org/drawingml/2006/main" noGrp="1"/>
+          </p:cNvSpPr>
+          <p:nvPr>
+            <p:ph type="body" idx="31"/>
+          </p:nvPr>
+        </p:nvSpPr>
+        <p:spPr>
+          <a:xfrm xmlns:a="http://schemas.openxmlformats.org/drawingml/2006/main">
+            <a:off x="869918" y="6572250"/>
+            <a:ext cx="28484227" cy="1047750"/>
+          </a:xfrm>
+        </p:spPr>
+        <p:txBody>
+          <a:bodyPr xmlns:a="http://schemas.openxmlformats.org/drawingml/2006/main" anchor="ctr"/>
           <a:lstStyle xmlns:a="http://schemas.openxmlformats.org/drawingml/2006/main"/>
           <a:p xmlns:a="http://schemas.openxmlformats.org/drawingml/2006/main">
             <a:pPr>
-              <a:defRPr>
+              <a:defRPr sz="4500" b="1">
+                <a:solidFill>
+                  <a:srgbClr val="004C97"/>
+                </a:solidFill>
                 <a:latin typeface="Arial"/>
                 <a:ea typeface="Arial"/>
                 <a:cs typeface="Arial"/>
               </a:defRPr>
             </a:pPr>
             <a:r>
-              <a:rPr>
+              <a:rPr sz="4500" b="1">
+                <a:solidFill>
+                  <a:srgbClr val="004C97"/>
+                </a:solidFill>
                 <a:latin typeface="Arial"/>
                 <a:ea typeface="Arial"/>
                 <a:cs typeface="Arial"/>
               </a:rPr>
-              <a:t>2,000 spills; 4,000 H/V curve cases; 1,000 stratified validation cases; 5 held-out-digitizer folds. H Best-5 blind agreement 9.1%; V Best-12 26.3%. Median IQR change vs corrected Best-1: H -0.0024, V 0.001. Finite full-buffer pick coverage: H 99.7%, V 80.3%. Intensity weighting retained 0/240 tested effects.</a:t>
-            </a:r>
-          </a:p>
-        </p:txBody>
-      </p:sp>
-      <p:sp>
-        <p:nvSpPr>
-          <p:cNvPr id="11" name="Text Placeholder 10">
-            <a:extLst xmlns:a="http://schemas.openxmlformats.org/drawingml/2006/main">
-              <a:ext uri="{FF2B5EF4-FFF2-40B4-BE49-F238E27FC236}">
-                <a16:creationId xmlns:a16="http://schemas.microsoft.com/office/drawing/2014/main" id="{D951D0B9-C16D-478C-883C-FBEC31B356DB}"/>
-              </a:ext>
-            </a:extLst>
-          </p:cNvPr>
-          <p:cNvSpPr>
-            <a:spLocks xmlns:a="http://schemas.openxmlformats.org/drawingml/2006/main" noGrp="1"/>
-          </p:cNvSpPr>
-          <p:nvPr>
-            <p:ph type="body" idx="31"/>
-          </p:nvPr>
-        </p:nvSpPr>
-        <p:spPr>
-          <a:xfrm xmlns:a="http://schemas.openxmlformats.org/drawingml/2006/main">
-            <a:off x="908030" y="31720556"/>
-            <a:ext cx="19199520" cy="1449970"/>
+              <a:t>DOES THE CANDIDATE PERSIST FOR 50,000 TURNS?</a:t>
+            </a:r>
+          </a:p>
+        </p:txBody>
+      </p:sp>
+      <p:sp>
+        <p:nvSpPr>
+          <p:cNvPr id="2" name="Text Placeholder 1">
+            <a:extLst xmlns:a="http://schemas.openxmlformats.org/drawingml/2006/main">
+              <a:ext uri="{FF2B5EF4-FFF2-40B4-BE49-F238E27FC236}">
+                <a16:creationId xmlns:a16="http://schemas.microsoft.com/office/drawing/2014/main" id="{672D8A87-C037-433C-852C-ED65B368B256}"/>
+              </a:ext>
+            </a:extLst>
+          </p:cNvPr>
+          <p:cNvSpPr>
+            <a:spLocks xmlns:a="http://schemas.openxmlformats.org/drawingml/2006/main" noGrp="1"/>
+          </p:cNvSpPr>
+          <p:nvPr>
+            <p:ph type="body" idx="35"/>
+          </p:nvPr>
+        </p:nvSpPr>
+        <p:spPr>
+          <a:xfrm xmlns:a="http://schemas.openxmlformats.org/drawingml/2006/main">
+            <a:off x="967359" y="31432500"/>
+            <a:ext cx="13573125" cy="1190625"/>
           </a:xfrm>
         </p:spPr>
         <p:txBody>
@@ -4114,43 +4162,49 @@
           <a:lstStyle xmlns:a="http://schemas.openxmlformats.org/drawingml/2006/main"/>
           <a:p xmlns:a="http://schemas.openxmlformats.org/drawingml/2006/main">
             <a:pPr>
-              <a:defRPr>
+              <a:defRPr sz="2700" b="1">
+                <a:solidFill>
+                  <a:srgbClr val="004C97"/>
+                </a:solidFill>
                 <a:latin typeface="Arial"/>
                 <a:ea typeface="Arial"/>
                 <a:cs typeface="Arial"/>
               </a:defRPr>
             </a:pPr>
             <a:r>
-              <a:rPr>
+              <a:rPr sz="2700" b="1">
+                <a:solidFill>
+                  <a:srgbClr val="004C97"/>
+                </a:solidFill>
                 <a:latin typeface="Arial"/>
                 <a:ea typeface="Arial"/>
                 <a:cs typeface="Arial"/>
               </a:rPr>
-              <a:t>Exact-paired 50,000-turn density versus the audited legacy selector: H Best-5 355,688 picks; V Best-12 286,646. Legacy-to-selected change includes selector repair; color is pick probability, not power.</a:t>
-            </a:r>
-          </a:p>
-        </p:txBody>
-      </p:sp>
-      <p:sp>
-        <p:nvSpPr>
-          <p:cNvPr id="2" name="Text Placeholder 1">
-            <a:extLst xmlns:a="http://schemas.openxmlformats.org/drawingml/2006/main">
-              <a:ext uri="{FF2B5EF4-FFF2-40B4-BE49-F238E27FC236}">
-                <a16:creationId xmlns:a16="http://schemas.microsoft.com/office/drawing/2014/main" id="{672D8A87-C037-433C-852C-ED65B368B256}"/>
-              </a:ext>
-            </a:extLst>
-          </p:cNvPr>
-          <p:cNvSpPr>
-            <a:spLocks xmlns:a="http://schemas.openxmlformats.org/drawingml/2006/main" noGrp="1"/>
-          </p:cNvSpPr>
-          <p:nvPr>
-            <p:ph type="body" idx="35"/>
-          </p:nvPr>
-        </p:nvSpPr>
-        <p:spPr>
-          <a:xfrm xmlns:a="http://schemas.openxmlformats.org/drawingml/2006/main">
-            <a:off x="967341" y="21081888"/>
-            <a:ext cx="8829949" cy="1596563"/>
+              <a:t>H: Best-5 reached 9.1%. The null band ends at 8.9% - promising, not decisive.</a:t>
+            </a:r>
+          </a:p>
+        </p:txBody>
+      </p:sp>
+      <p:sp>
+        <p:nvSpPr>
+          <p:cNvPr id="4" name="Text Placeholder 3">
+            <a:extLst xmlns:a="http://schemas.openxmlformats.org/drawingml/2006/main">
+              <a:ext uri="{FF2B5EF4-FFF2-40B4-BE49-F238E27FC236}">
+                <a16:creationId xmlns:a16="http://schemas.microsoft.com/office/drawing/2014/main" id="{D41CDA26-A61B-4535-A2B2-2F73AEC52382}"/>
+              </a:ext>
+            </a:extLst>
+          </p:cNvPr>
+          <p:cNvSpPr>
+            <a:spLocks xmlns:a="http://schemas.openxmlformats.org/drawingml/2006/main" noGrp="1"/>
+          </p:cNvSpPr>
+          <p:nvPr>
+            <p:ph type="body" idx="37"/>
+          </p:nvPr>
+        </p:nvSpPr>
+        <p:spPr>
+          <a:xfrm xmlns:a="http://schemas.openxmlformats.org/drawingml/2006/main">
+            <a:off x="15781020" y="31432500"/>
+            <a:ext cx="13573125" cy="1190625"/>
           </a:xfrm>
         </p:spPr>
         <p:txBody>
@@ -4158,43 +4212,49 @@
           <a:lstStyle xmlns:a="http://schemas.openxmlformats.org/drawingml/2006/main"/>
           <a:p xmlns:a="http://schemas.openxmlformats.org/drawingml/2006/main">
             <a:pPr>
-              <a:defRPr>
+              <a:defRPr sz="2700" b="1">
+                <a:solidFill>
+                  <a:srgbClr val="004C97"/>
+                </a:solidFill>
                 <a:latin typeface="Arial"/>
                 <a:ea typeface="Arial"/>
                 <a:cs typeface="Arial"/>
               </a:defRPr>
             </a:pPr>
             <a:r>
-              <a:rPr>
+              <a:rPr sz="2700" b="1">
+                <a:solidFill>
+                  <a:srgbClr val="004C97"/>
+                </a:solidFill>
                 <a:latin typeface="Arial"/>
                 <a:ea typeface="Arial"/>
                 <a:cs typeface="Arial"/>
               </a:rPr>
-              <a:t>H Best-5: blind full-band selected/held-out agreement 9.1% [7.9%, 9.8%]; median |Delta q| 0.0161. Reduced-sample knees span 2-13 in 5/7 runs; 2 unresolved.</a:t>
-            </a:r>
-          </a:p>
-        </p:txBody>
-      </p:sp>
-      <p:sp>
-        <p:nvSpPr>
-          <p:cNvPr id="4" name="Text Placeholder 3">
-            <a:extLst xmlns:a="http://schemas.openxmlformats.org/drawingml/2006/main">
-              <a:ext uri="{FF2B5EF4-FFF2-40B4-BE49-F238E27FC236}">
-                <a16:creationId xmlns:a16="http://schemas.microsoft.com/office/drawing/2014/main" id="{D41CDA26-A61B-4535-A2B2-2F73AEC52382}"/>
-              </a:ext>
-            </a:extLst>
-          </p:cNvPr>
-          <p:cNvSpPr>
-            <a:spLocks xmlns:a="http://schemas.openxmlformats.org/drawingml/2006/main" noGrp="1"/>
-          </p:cNvSpPr>
-          <p:nvPr>
-            <p:ph type="body" idx="37"/>
-          </p:nvPr>
-        </p:nvSpPr>
-        <p:spPr>
-          <a:xfrm xmlns:a="http://schemas.openxmlformats.org/drawingml/2006/main">
-            <a:off x="10955872" y="21081888"/>
-            <a:ext cx="8957728" cy="1596563"/>
+              <a:t>V: Best-12 reached 26.3%. The null band ends at 18.3% - a clear separation.</a:t>
+            </a:r>
+          </a:p>
+        </p:txBody>
+      </p:sp>
+      <p:sp>
+        <p:nvSpPr>
+          <p:cNvPr id="5" name="Text Placeholder 4">
+            <a:extLst xmlns:a="http://schemas.openxmlformats.org/drawingml/2006/main">
+              <a:ext uri="{FF2B5EF4-FFF2-40B4-BE49-F238E27FC236}">
+                <a16:creationId xmlns:a16="http://schemas.microsoft.com/office/drawing/2014/main" id="{3D9AC6E8-924E-43FB-9E56-BB6083888999}"/>
+              </a:ext>
+            </a:extLst>
+          </p:cNvPr>
+          <p:cNvSpPr>
+            <a:spLocks xmlns:a="http://schemas.openxmlformats.org/drawingml/2006/main" noGrp="1"/>
+          </p:cNvSpPr>
+          <p:nvPr>
+            <p:ph type="body" idx="30"/>
+          </p:nvPr>
+        </p:nvSpPr>
+        <p:spPr>
+          <a:xfrm xmlns:a="http://schemas.openxmlformats.org/drawingml/2006/main">
+            <a:off x="869918" y="32623125"/>
+            <a:ext cx="13811250" cy="714375"/>
           </a:xfrm>
         </p:spPr>
         <p:txBody>
@@ -4202,67 +4262,51 @@
           <a:lstStyle xmlns:a="http://schemas.openxmlformats.org/drawingml/2006/main"/>
           <a:p xmlns:a="http://schemas.openxmlformats.org/drawingml/2006/main">
             <a:pPr>
-              <a:defRPr>
+              <a:defRPr sz="2250" b="1">
+                <a:solidFill>
+                  <a:srgbClr val="004C97"/>
+                </a:solidFill>
                 <a:latin typeface="Arial"/>
                 <a:ea typeface="Arial"/>
                 <a:cs typeface="Arial"/>
               </a:defRPr>
             </a:pPr>
             <a:r>
-              <a:rPr>
+              <a:rPr sz="2250" b="1">
+                <a:solidFill>
+                  <a:srgbClr val="004C97"/>
+                </a:solidFill>
                 <a:latin typeface="Arial"/>
                 <a:ea typeface="Arial"/>
                 <a:cs typeface="Arial"/>
               </a:rPr>
-              <a:t>V Best-12: blind full-band selected/held-out agreement 26.3% [19.1%, 33.0%]; median |Delta q| 0.0107. Reduced-sample knees span 10-28 in 6/7 runs; 1 unresolved.</a:t>
-            </a:r>
-          </a:p>
-        </p:txBody>
-      </p:sp>
-      <p:sp>
-        <p:nvSpPr>
-          <p:cNvPr id="5" name="Text Placeholder 4">
-            <a:extLst xmlns:a="http://schemas.openxmlformats.org/drawingml/2006/main">
-              <a:ext uri="{FF2B5EF4-FFF2-40B4-BE49-F238E27FC236}">
-                <a16:creationId xmlns:a16="http://schemas.microsoft.com/office/drawing/2014/main" id="{3D9AC6E8-924E-43FB-9E56-BB6083888999}"/>
-              </a:ext>
-            </a:extLst>
-          </p:cNvPr>
-          <p:cNvSpPr>
-            <a:spLocks xmlns:a="http://schemas.openxmlformats.org/drawingml/2006/main" noGrp="1"/>
-          </p:cNvSpPr>
-          <p:nvPr>
-            <p:ph type="body" idx="30"/>
-          </p:nvPr>
-        </p:nvSpPr>
-        <p:spPr>
-          <a:xfrm xmlns:a="http://schemas.openxmlformats.org/drawingml/2006/main">
-            <a:off x="20987430" y="17385434"/>
-            <a:ext cx="8366759" cy="2106651"/>
-          </a:xfrm>
-        </p:spPr>
-        <p:txBody>
-          <a:bodyPr xmlns:a="http://schemas.openxmlformats.org/drawingml/2006/main"/>
-          <a:lstStyle xmlns:a="http://schemas.openxmlformats.org/drawingml/2006/main"/>
-          <a:p xmlns:a="http://schemas.openxmlformats.org/drawingml/2006/main">
-            <a:pPr>
-              <a:defRPr>
-                <a:latin typeface="Arial"/>
-                <a:ea typeface="Arial"/>
-                <a:cs typeface="Arial"/>
-              </a:defRPr>
-            </a:pPr>
-            <a:r>
-              <a:rPr>
-                <a:latin typeface="Arial"/>
-                <a:ea typeface="Arial"/>
-                <a:cs typeface="Arial"/>
-              </a:rPr>
-              <a:t>Selected H Best-5 and V Best-12 P10-P90 width minus corrected adaptive Best-1 on exact paired spill/windows. Negative is narrower; zero is no ensemble-size difference.</a:t>
-            </a:r>
-          </a:p>
-        </p:txBody>
-      </p:sp>
+              <a:t>The loop at right is the Delivery Ring. Its position readouts do not behave equally.</a:t>
+            </a:r>
+          </a:p>
+        </p:txBody>
+      </p:sp>
+      <p:pic>
+        <p:nvPicPr>
+          <p:cNvPr id="130" name=""/>
+          <p:cNvPicPr>
+            <a:picLocks xmlns:a="http://schemas.openxmlformats.org/drawingml/2006/main" noChangeAspect="1"/>
+          </p:cNvPicPr>
+          <p:nvPr/>
+        </p:nvPicPr>
+        <p:blipFill>
+          <a:blip xmlns:r="http://schemas.openxmlformats.org/officeDocument/2006/relationships" xmlns:a="http://schemas.openxmlformats.org/drawingml/2006/main" r:embed="R7047ecec9e1148ef"/>
+          <a:stretch xmlns:a="http://schemas.openxmlformats.org/drawingml/2006/main"/>
+        </p:blipFill>
+        <p:spPr>
+          <a:xfrm xmlns:a="http://schemas.openxmlformats.org/drawingml/2006/main">
+            <a:off x="1737218" y="33337500"/>
+            <a:ext cx="12076651" cy="4762500"/>
+          </a:xfrm>
+          <a:prstGeom xmlns:a="http://schemas.openxmlformats.org/drawingml/2006/main" prst="rect">
+            <a:avLst/>
+          </a:prstGeom>
+        </p:spPr>
+      </p:pic>
       <p:pic>
         <p:nvPicPr>
           <p:cNvPr id="131" name=""/>
@@ -4272,13 +4316,13 @@
           <p:nvPr/>
         </p:nvPicPr>
         <p:blipFill>
-          <a:blip xmlns:r="http://schemas.openxmlformats.org/officeDocument/2006/relationships" xmlns:a="http://schemas.openxmlformats.org/drawingml/2006/main" r:embed="R30d76a73159544af"/>
+          <a:blip xmlns:r="http://schemas.openxmlformats.org/officeDocument/2006/relationships" xmlns:a="http://schemas.openxmlformats.org/drawingml/2006/main" r:embed="Rd1e4a754dcb042ba"/>
           <a:stretch xmlns:a="http://schemas.openxmlformats.org/drawingml/2006/main"/>
         </p:blipFill>
         <p:spPr>
           <a:xfrm xmlns:a="http://schemas.openxmlformats.org/drawingml/2006/main">
-            <a:off x="927426" y="14759619"/>
-            <a:ext cx="8491910" cy="4852520"/>
+            <a:off x="1369981" y="24193500"/>
+            <a:ext cx="12668250" cy="7239000"/>
           </a:xfrm>
           <a:prstGeom xmlns:a="http://schemas.openxmlformats.org/drawingml/2006/main" prst="rect">
             <a:avLst/>
@@ -4294,13 +4338,13 @@
           <p:nvPr/>
         </p:nvPicPr>
         <p:blipFill>
-          <a:blip xmlns:r="http://schemas.openxmlformats.org/officeDocument/2006/relationships" xmlns:a="http://schemas.openxmlformats.org/drawingml/2006/main" r:embed="R04338f12f25d4eac"/>
+          <a:blip xmlns:r="http://schemas.openxmlformats.org/officeDocument/2006/relationships" xmlns:a="http://schemas.openxmlformats.org/drawingml/2006/main" r:embed="Rb62d53f56e1c410a"/>
           <a:stretch xmlns:a="http://schemas.openxmlformats.org/drawingml/2006/main"/>
         </p:blipFill>
         <p:spPr>
           <a:xfrm xmlns:a="http://schemas.openxmlformats.org/drawingml/2006/main">
-            <a:off x="10955872" y="14865941"/>
-            <a:ext cx="8143213" cy="4653265"/>
+            <a:off x="16185833" y="24193500"/>
+            <a:ext cx="12668250" cy="7239000"/>
           </a:xfrm>
           <a:prstGeom xmlns:a="http://schemas.openxmlformats.org/drawingml/2006/main" prst="rect">
             <a:avLst/>
@@ -4316,57 +4360,13 @@
           <p:nvPr/>
         </p:nvPicPr>
         <p:blipFill>
-          <a:blip xmlns:r="http://schemas.openxmlformats.org/officeDocument/2006/relationships" xmlns:a="http://schemas.openxmlformats.org/drawingml/2006/main" r:embed="R80b20c77825e4030"/>
+          <a:blip xmlns:r="http://schemas.openxmlformats.org/officeDocument/2006/relationships" xmlns:a="http://schemas.openxmlformats.org/drawingml/2006/main" r:embed="Rf7431b2dee53429a"/>
           <a:stretch xmlns:a="http://schemas.openxmlformats.org/drawingml/2006/main"/>
         </p:blipFill>
         <p:spPr>
           <a:xfrm xmlns:a="http://schemas.openxmlformats.org/drawingml/2006/main">
-            <a:off x="927427" y="23919158"/>
-            <a:ext cx="18986173" cy="7119815"/>
-          </a:xfrm>
-          <a:prstGeom xmlns:a="http://schemas.openxmlformats.org/drawingml/2006/main" prst="rect">
-            <a:avLst/>
-          </a:prstGeom>
-        </p:spPr>
-      </p:pic>
-      <p:pic>
-        <p:nvPicPr>
-          <p:cNvPr id="134" name=""/>
-          <p:cNvPicPr>
-            <a:picLocks xmlns:a="http://schemas.openxmlformats.org/drawingml/2006/main" noChangeAspect="1"/>
-          </p:cNvPicPr>
-          <p:nvPr/>
-        </p:nvPicPr>
-        <p:blipFill>
-          <a:blip xmlns:r="http://schemas.openxmlformats.org/officeDocument/2006/relationships" xmlns:a="http://schemas.openxmlformats.org/drawingml/2006/main" r:embed="R3beb6c57e05e4ccf"/>
-          <a:stretch xmlns:a="http://schemas.openxmlformats.org/drawingml/2006/main"/>
-        </p:blipFill>
-        <p:spPr>
-          <a:xfrm xmlns:a="http://schemas.openxmlformats.org/drawingml/2006/main">
-            <a:off x="22308741" y="7721489"/>
-            <a:ext cx="6074163" cy="9490880"/>
-          </a:xfrm>
-          <a:prstGeom xmlns:a="http://schemas.openxmlformats.org/drawingml/2006/main" prst="rect">
-            <a:avLst/>
-          </a:prstGeom>
-        </p:spPr>
-      </p:pic>
-      <p:pic>
-        <p:nvPicPr>
-          <p:cNvPr id="135" name=""/>
-          <p:cNvPicPr>
-            <a:picLocks xmlns:a="http://schemas.openxmlformats.org/drawingml/2006/main" noChangeAspect="1"/>
-          </p:cNvPicPr>
-          <p:nvPr/>
-        </p:nvPicPr>
-        <p:blipFill>
-          <a:blip xmlns:r="http://schemas.openxmlformats.org/officeDocument/2006/relationships" xmlns:a="http://schemas.openxmlformats.org/drawingml/2006/main" r:embed="Re8596385bd5545fd"/>
-          <a:stretch xmlns:a="http://schemas.openxmlformats.org/drawingml/2006/main"/>
-        </p:blipFill>
-        <p:spPr>
-          <a:xfrm xmlns:a="http://schemas.openxmlformats.org/drawingml/2006/main">
-            <a:off x="20986750" y="27081680"/>
-            <a:ext cx="8367713" cy="4662012"/>
+            <a:off x="3681413" y="7620000"/>
+            <a:ext cx="22860000" cy="14439900"/>
           </a:xfrm>
           <a:prstGeom xmlns:a="http://schemas.openxmlformats.org/drawingml/2006/main" prst="rect">
             <a:avLst/>

</xml_diff>